<commit_message>
Add official Vercel live deployment link https://plantbrain-eight.vercel.app/ to README, deployment docs, and presentation
</commit_message>
<xml_diff>
--- a/PlantBrain_Presentation.pptx
+++ b/PlantBrain_Presentation.pptx
@@ -4282,14 +4282,14 @@
               <a:spcBef>
                 <a:spcPts val="600"/>
               </a:spcBef>
-              <a:defRPr sz="1200">
-                <a:solidFill>
-                  <a:srgbClr val="F8FAFC"/>
-                </a:solidFill>
-              </a:defRPr>
-            </a:pPr>
-            <a:r>
-              <a:t>• Live Application: Render (Backend API) + Vercel (React Frontend)</a:t>
+              <a:defRPr sz="1300" b="1">
+                <a:solidFill>
+                  <a:srgbClr val="10B981"/>
+                </a:solidFill>
+              </a:defRPr>
+            </a:pPr>
+            <a:r>
+              <a:t>• Official Live Application: https://plantbrain-eight.vercel.app/</a:t>
             </a:r>
           </a:p>
           <a:p>

</xml_diff>